<commit_message>
Add planned ISO 27001/27017/27018 certifications to certification slide
Co-Authored-By: Claude Sonnet 5.5 <noreply@anthropic.com>
Claude-Session: https://claude.ai/code/session_01Suo9gkBTWtUDD7LdnsuAe3
</commit_message>
<xml_diff>
--- a/KTPH_RFP_MONIT_Presentation.pptx
+++ b/KTPH_RFP_MONIT_Presentation.pptx
@@ -130,28 +130,28 @@
   <p:extLst>
     <p:ext uri="{521415D9-36F7-43E2-AB2F-B90AF26B5E84}">
       <p14:sectionLst xmlns:p14="http://schemas.microsoft.com/office/powerpoint/2010/main">
-        <p14:section name="Introduction" id="{1e8f63e5-c919-b2a2-63f4-50bcbae0ba8e}">
+        <p14:section name="Introduction" id="{8c5cfb80-ac37-4b02-5c0f-89d67687ec6f}">
           <p14:sldIdLst>
             <p14:sldId id="256"/>
           </p14:sldIdLst>
         </p14:section>
-        <p14:section name="Executive summary" id="{60f4c83e-376d-cf59-d364-01e8506b5870}">
+        <p14:section name="Executive summary" id="{8525f87d-d1c7-21aa-5317-c61112cab170}">
           <p14:sldIdLst>
             <p14:sldId id="257"/>
             <p14:sldId id="258"/>
           </p14:sldIdLst>
         </p14:section>
-        <p14:section name="1 · Company introduction" id="{79c1ada3-35e5-2b58-2f3a-a6e9e8be3a4e}">
+        <p14:section name="1 · Company introduction" id="{98243c24-1700-4ddc-c87e-33d6d3aa57e7}">
           <p14:sldIdLst>
             <p14:sldId id="259"/>
           </p14:sldIdLst>
         </p14:section>
-        <p14:section name="2 · Industry certifications and standards" id="{6f764a6e-cc37-2b86-704e-791c5e4b83ab}">
+        <p14:section name="2 · Industry certifications and standards" id="{f8497909-e92e-def8-1bdd-4540b7d7e159}">
           <p14:sldIdLst>
             <p14:sldId id="260"/>
           </p14:sldIdLst>
         </p14:section>
-        <p14:section name="3 · Smart diaper system" id="{de56ab53-1fbc-18df-e4b6-b0deb33e7ab0}">
+        <p14:section name="3 · Smart diaper system" id="{ff954478-ff61-24f0-364b-d5777d0a0778}">
           <p14:sldIdLst>
             <p14:sldId id="261"/>
             <p14:sldId id="262"/>
@@ -160,7 +160,7 @@
             <p14:sldId id="265"/>
           </p14:sldIdLst>
         </p14:section>
-        <p14:section name="4 · Understanding of the project" id="{7bc8d2ad-750e-f741-fb3e-249e93c527a8}">
+        <p14:section name="4 · Understanding of the project" id="{63d0c49b-0660-a61f-5295-9e51c5f24e2b}">
           <p14:sldIdLst>
             <p14:sldId id="266"/>
             <p14:sldId id="267"/>
@@ -169,22 +169,22 @@
             <p14:sldId id="270"/>
           </p14:sldIdLst>
         </p14:section>
-        <p14:section name="5 · Project timeline" id="{36ff1d26-6fe8-860f-1b10-2f3f4760ae83}">
+        <p14:section name="5 · Project timeline" id="{8fc0a309-6982-f2ab-a04d-3c0cd0b5511d}">
           <p14:sldIdLst>
             <p14:sldId id="271"/>
           </p14:sldIdLst>
         </p14:section>
-        <p14:section name="6 · References and track record" id="{f85bd864-d7c6-805f-0841-b3f961c14323}">
+        <p14:section name="6 · References and track record" id="{1f7192a1-1cb7-8b10-de65-6ae4b2be87ab}">
           <p14:sldIdLst>
             <p14:sldId id="272"/>
           </p14:sldIdLst>
         </p14:section>
-        <p14:section name="7 · Sustainability initiatives" id="{149572d1-d6b2-aa54-4447-0db4dfb9fdce}">
+        <p14:section name="7 · Sustainability initiatives" id="{a14521a6-fd97-3f61-c70e-eda15332aeb0}">
           <p14:sldIdLst>
             <p14:sldId id="273"/>
           </p14:sldIdLst>
         </p14:section>
-        <p14:section name="8 · Network connectivity and relay devices" id="{46c0e378-d681-2ec3-189a-1804308a03ee}">
+        <p14:section name="8 · Network connectivity and relay devices" id="{3c874f95-573b-1372-4346-2ef3ab70f52e}">
           <p14:sldIdLst>
             <p14:sldId id="274"/>
             <p14:sldId id="275"/>
@@ -192,7 +192,7 @@
             <p14:sldId id="277"/>
           </p14:sldIdLst>
         </p14:section>
-        <p14:section name="Discussion" id="{b706e868-dd75-75d6-8526-2dd68d0fb75e}">
+        <p14:section name="Discussion" id="{7210e81f-fd16-28f7-8bf7-9d2949c4dc78}">
           <p14:sldIdLst>
             <p14:sldId id="278"/>
             <p14:sldId id="279"/>
@@ -2274,7 +2274,7 @@
           <a:p>
             <a:r>
               <a:rPr lang="en-US" dirty="0"/>
-              <a:t>Provide certificate numbers, issuing bodies and expiry dates, and append copies. Note that ALPS is ISO14000 and OSHA certified and expects vendors to follow its environmental and safety requirements. The consent form requires medical devices to be HSA-registered - confirm the device class and registration for the sensor.</a:t>
+              <a:t>ISO/IEC 27001, 27017 and 27018 are planned (not yet certified) - state the certification body, audit stage and target date, and do not describe them as held until issued. Provide certificate numbers, issuing bodies and expiry dates for the other items, and append copies. Note that ALPS is ISO14000 and OSHA certified and expects vendors to follow its environmental and safety requirements. The consent form requires medical devices to be HSA-registered - confirm the device class and registration for the sensor.</a:t>
             </a:r>
             <a:endParaRPr lang="en-US" dirty="0"/>
           </a:p>
@@ -15983,7 +15983,7 @@
                   <a:schemeClr val="tx1"/>
                 </a:solidFill>
               </a:rPr>
-              <a:t>Clinically validated sensor with measured detection performance; certified to the standards ALPS expects (BizSAFE, ISO, IMDA, HSA).</a:t>
+              <a:t>Clinically validated sensor with measured detection performance; certified or certifying to the standards ALPS expects (BizSAFE, ISO incl. 27001/27017/27018, IMDA, HSA).</a:t>
             </a:r>
             <a:endParaRPr lang="en-US" sz="1300" dirty="0"/>
           </a:p>
@@ -24156,7 +24156,7 @@
                   <a:schemeClr val="tx2"/>
                 </a:solidFill>
               </a:rPr>
-              <a:t>Our certifications cover safety, quality, security and the network-device rules for hospital Wi-Fi</a:t>
+              <a:t>Our certifications, plus ISO 27001/27017/27018 now planned, cover safety, quality and information security</a:t>
             </a:r>
             <a:endParaRPr lang="en-US" sz="2200" dirty="0"/>
           </a:p>
@@ -24192,7 +24192,7 @@
                   <a:schemeClr val="accent4"/>
                 </a:solidFill>
               </a:rPr>
-              <a:t>Source: MONIT certificates; RFP Consent Form (HSA registration requirement); Section 1 clause 19 (ISO14000/OSHA). Attach copies in the proposal.</a:t>
+              <a:t>Source: MONIT certificates and certification plan; RFP Consent Form (HSA registration requirement); Section 1 clause 19 (ISO14000/OSHA). Attach copies in the proposal.</a:t>
             </a:r>
             <a:endParaRPr lang="en-US" sz="900" dirty="0"/>
           </a:p>
@@ -24213,7 +24213,7 @@
           </p:nvPr>
         </p:nvGraphicFramePr>
         <p:xfrm>
-          <a:off x="548640" y="1691640"/>
+          <a:off x="548640" y="1645920"/>
           <a:ext cx="11091672" cy="914400"/>
         </p:xfrm>
         <a:graphic>
@@ -24221,12 +24221,12 @@
             <a:tbl>
               <a:tblPr/>
               <a:tblGrid>
-                <a:gridCol w="3017520"/>
-                <a:gridCol w="4480560"/>
+                <a:gridCol w="3200400"/>
+                <a:gridCol w="4297680"/>
                 <a:gridCol w="2468880"/>
                 <a:gridCol w="1124712"/>
               </a:tblGrid>
-              <a:tr h="512064">
+              <a:tr h="420624">
                 <a:tc>
                   <a:txBody>
                     <a:bodyPr/>
@@ -24236,14 +24236,14 @@
                         <a:buNone/>
                       </a:pPr>
                       <a:r>
-                        <a:rPr lang="en-US" sz="1100" b="1" dirty="0">
+                        <a:rPr lang="en-US" sz="1050" b="1" dirty="0">
                           <a:solidFill>
                             <a:srgbClr val="FFFFFF"/>
                           </a:solidFill>
                         </a:rPr>
                         <a:t>Standard / certification</a:t>
                       </a:r>
-                      <a:endParaRPr lang="en-US" sz="1100" dirty="0"/>
+                      <a:endParaRPr lang="en-US" sz="1050" dirty="0"/>
                     </a:p>
                   </a:txBody>
                   <a:tcPr marL="73152" marR="73152" marT="45720" marB="45720" anchor="ctr">
@@ -24273,14 +24273,14 @@
                         <a:buNone/>
                       </a:pPr>
                       <a:r>
-                        <a:rPr lang="en-US" sz="1100" b="1" dirty="0">
+                        <a:rPr lang="en-US" sz="1050" b="1" dirty="0">
                           <a:solidFill>
                             <a:srgbClr val="FFFFFF"/>
                           </a:solidFill>
                         </a:rPr>
                         <a:t>Why it matters for this RFP</a:t>
                       </a:r>
-                      <a:endParaRPr lang="en-US" sz="1100" dirty="0"/>
+                      <a:endParaRPr lang="en-US" sz="1050" dirty="0"/>
                     </a:p>
                   </a:txBody>
                   <a:tcPr marL="73152" marR="73152" marT="45720" marB="45720" anchor="ctr">
@@ -24310,14 +24310,14 @@
                         <a:buNone/>
                       </a:pPr>
                       <a:r>
-                        <a:rPr lang="en-US" sz="1100" b="1" dirty="0">
+                        <a:rPr lang="en-US" sz="1050" b="1" dirty="0">
                           <a:solidFill>
                             <a:srgbClr val="FFFFFF"/>
                           </a:solidFill>
                         </a:rPr>
                         <a:t>Status / certificate no.</a:t>
                       </a:r>
-                      <a:endParaRPr lang="en-US" sz="1100" dirty="0"/>
+                      <a:endParaRPr lang="en-US" sz="1050" dirty="0"/>
                     </a:p>
                   </a:txBody>
                   <a:tcPr marL="73152" marR="73152" marT="45720" marB="45720" anchor="ctr">
@@ -24347,14 +24347,14 @@
                         <a:buNone/>
                       </a:pPr>
                       <a:r>
-                        <a:rPr lang="en-US" sz="1100" b="1" dirty="0">
+                        <a:rPr lang="en-US" sz="1050" b="1" dirty="0">
                           <a:solidFill>
                             <a:srgbClr val="FFFFFF"/>
                           </a:solidFill>
                         </a:rPr>
                         <a:t>Valid until</a:t>
                       </a:r>
-                      <a:endParaRPr lang="en-US" sz="1100" dirty="0"/>
+                      <a:endParaRPr lang="en-US" sz="1050" dirty="0"/>
                     </a:p>
                   </a:txBody>
                   <a:tcPr marL="73152" marR="73152" marT="45720" marB="45720" anchor="ctr">
@@ -24376,7 +24376,7 @@
                   </a:tcPr>
                 </a:tc>
               </a:tr>
-              <a:tr h="512064">
+              <a:tr h="420624">
                 <a:tc>
                   <a:txBody>
                     <a:bodyPr/>
@@ -24386,14 +24386,14 @@
                         <a:buNone/>
                       </a:pPr>
                       <a:r>
-                        <a:rPr lang="en-US" sz="1100" b="1" dirty="0">
+                        <a:rPr lang="en-US" sz="1050" b="1" dirty="0">
                           <a:solidFill>
                             <a:srgbClr val="1F2937"/>
                           </a:solidFill>
                         </a:rPr>
                         <a:t>BizSAFE (level 3 / Star)</a:t>
                       </a:r>
-                      <a:endParaRPr lang="en-US" sz="1100" dirty="0"/>
+                      <a:endParaRPr lang="en-US" sz="1050" dirty="0"/>
                     </a:p>
                   </a:txBody>
                   <a:tcPr marL="73152" marR="73152" marT="45720" marB="45720" anchor="ctr">
@@ -24429,14 +24429,14 @@
                         <a:buNone/>
                       </a:pPr>
                       <a:r>
-                        <a:rPr lang="en-US" sz="1100" dirty="0">
+                        <a:rPr lang="en-US" sz="1050" dirty="0">
                           <a:solidFill>
                             <a:srgbClr val="1F2937"/>
                           </a:solidFill>
                         </a:rPr>
                         <a:t>Contractor safety for on-site installation in hospitals</a:t>
                       </a:r>
-                      <a:endParaRPr lang="en-US" sz="1100" dirty="0"/>
+                      <a:endParaRPr lang="en-US" sz="1050" dirty="0"/>
                     </a:p>
                   </a:txBody>
                   <a:tcPr marL="73152" marR="73152" marT="45720" marB="45720" anchor="ctr">
@@ -24472,14 +24472,14 @@
                         <a:buNone/>
                       </a:pPr>
                       <a:r>
-                        <a:rPr lang="en-US" sz="1100" i="1" dirty="0">
+                        <a:rPr lang="en-US" sz="1050" i="1" dirty="0">
                           <a:solidFill>
                             <a:srgbClr val="7A4F00"/>
                           </a:solidFill>
                         </a:rPr>
                         <a:t>[INPUT REQUIRED] level &amp; cert no.</a:t>
                       </a:r>
-                      <a:endParaRPr lang="en-US" sz="1100" dirty="0"/>
+                      <a:endParaRPr lang="en-US" sz="1050" dirty="0"/>
                     </a:p>
                   </a:txBody>
                   <a:tcPr marL="73152" marR="73152" marT="45720" marB="45720" anchor="ctr">
@@ -24515,14 +24515,14 @@
                         <a:buNone/>
                       </a:pPr>
                       <a:r>
-                        <a:rPr lang="en-US" sz="1100" i="1" dirty="0">
+                        <a:rPr lang="en-US" sz="1050" i="1" dirty="0">
                           <a:solidFill>
                             <a:srgbClr val="7A4F00"/>
                           </a:solidFill>
                         </a:rPr>
                         <a:t>[INPUT]</a:t>
                       </a:r>
-                      <a:endParaRPr lang="en-US" sz="1100" dirty="0"/>
+                      <a:endParaRPr lang="en-US" sz="1050" dirty="0"/>
                     </a:p>
                   </a:txBody>
                   <a:tcPr marL="73152" marR="73152" marT="45720" marB="45720" anchor="ctr">
@@ -24550,7 +24550,7 @@
                   </a:tcPr>
                 </a:tc>
               </a:tr>
-              <a:tr h="512064">
+              <a:tr h="420624">
                 <a:tc>
                   <a:txBody>
                     <a:bodyPr/>
@@ -24560,14 +24560,14 @@
                         <a:buNone/>
                       </a:pPr>
                       <a:r>
-                        <a:rPr lang="en-US" sz="1100" b="1" dirty="0">
+                        <a:rPr lang="en-US" sz="1050" b="1" dirty="0">
                           <a:solidFill>
                             <a:srgbClr val="1F2937"/>
                           </a:solidFill>
                         </a:rPr>
                         <a:t>ISO 9001 – Quality management</a:t>
                       </a:r>
-                      <a:endParaRPr lang="en-US" sz="1100" dirty="0"/>
+                      <a:endParaRPr lang="en-US" sz="1050" dirty="0"/>
                     </a:p>
                   </a:txBody>
                   <a:tcPr marL="73152" marR="73152" marT="45720" marB="45720" anchor="ctr">
@@ -24603,14 +24603,14 @@
                         <a:buNone/>
                       </a:pPr>
                       <a:r>
-                        <a:rPr lang="en-US" sz="1100" dirty="0">
+                        <a:rPr lang="en-US" sz="1050" dirty="0">
                           <a:solidFill>
                             <a:srgbClr val="1F2937"/>
                           </a:solidFill>
                         </a:rPr>
                         <a:t>Consistent delivery, QA and service processes</a:t>
                       </a:r>
-                      <a:endParaRPr lang="en-US" sz="1100" dirty="0"/>
+                      <a:endParaRPr lang="en-US" sz="1050" dirty="0"/>
                     </a:p>
                   </a:txBody>
                   <a:tcPr marL="73152" marR="73152" marT="45720" marB="45720" anchor="ctr">
@@ -24646,14 +24646,14 @@
                         <a:buNone/>
                       </a:pPr>
                       <a:r>
-                        <a:rPr lang="en-US" sz="1100" i="1" dirty="0">
+                        <a:rPr lang="en-US" sz="1050" i="1" dirty="0">
                           <a:solidFill>
                             <a:srgbClr val="7A4F00"/>
                           </a:solidFill>
                         </a:rPr>
                         <a:t>[INPUT REQUIRED]</a:t>
                       </a:r>
-                      <a:endParaRPr lang="en-US" sz="1100" dirty="0"/>
+                      <a:endParaRPr lang="en-US" sz="1050" dirty="0"/>
                     </a:p>
                   </a:txBody>
                   <a:tcPr marL="73152" marR="73152" marT="45720" marB="45720" anchor="ctr">
@@ -24689,14 +24689,14 @@
                         <a:buNone/>
                       </a:pPr>
                       <a:r>
-                        <a:rPr lang="en-US" sz="1100" i="1" dirty="0">
+                        <a:rPr lang="en-US" sz="1050" i="1" dirty="0">
                           <a:solidFill>
                             <a:srgbClr val="7A4F00"/>
                           </a:solidFill>
                         </a:rPr>
                         <a:t>[INPUT]</a:t>
                       </a:r>
-                      <a:endParaRPr lang="en-US" sz="1100" dirty="0"/>
+                      <a:endParaRPr lang="en-US" sz="1050" dirty="0"/>
                     </a:p>
                   </a:txBody>
                   <a:tcPr marL="73152" marR="73152" marT="45720" marB="45720" anchor="ctr">
@@ -24724,7 +24724,7 @@
                   </a:tcPr>
                 </a:tc>
               </a:tr>
-              <a:tr h="512064">
+              <a:tr h="420624">
                 <a:tc>
                   <a:txBody>
                     <a:bodyPr/>
@@ -24734,14 +24734,14 @@
                         <a:buNone/>
                       </a:pPr>
                       <a:r>
-                        <a:rPr lang="en-US" sz="1100" b="1" dirty="0">
+                        <a:rPr lang="en-US" sz="1050" b="1" dirty="0">
                           <a:solidFill>
                             <a:srgbClr val="1F2937"/>
                           </a:solidFill>
                         </a:rPr>
                         <a:t>ISO 13485 – Medical devices QMS</a:t>
                       </a:r>
-                      <a:endParaRPr lang="en-US" sz="1100" dirty="0"/>
+                      <a:endParaRPr lang="en-US" sz="1050" dirty="0"/>
                     </a:p>
                   </a:txBody>
                   <a:tcPr marL="73152" marR="73152" marT="45720" marB="45720" anchor="ctr">
@@ -24777,14 +24777,14 @@
                         <a:buNone/>
                       </a:pPr>
                       <a:r>
-                        <a:rPr lang="en-US" sz="1100" dirty="0">
+                        <a:rPr lang="en-US" sz="1050" dirty="0">
                           <a:solidFill>
                             <a:srgbClr val="1F2937"/>
                           </a:solidFill>
                         </a:rPr>
                         <a:t>Design &amp; manufacture of the sensor as a medical device</a:t>
                       </a:r>
-                      <a:endParaRPr lang="en-US" sz="1100" dirty="0"/>
+                      <a:endParaRPr lang="en-US" sz="1050" dirty="0"/>
                     </a:p>
                   </a:txBody>
                   <a:tcPr marL="73152" marR="73152" marT="45720" marB="45720" anchor="ctr">
@@ -24820,14 +24820,14 @@
                         <a:buNone/>
                       </a:pPr>
                       <a:r>
-                        <a:rPr lang="en-US" sz="1100" i="1" dirty="0">
+                        <a:rPr lang="en-US" sz="1050" i="1" dirty="0">
                           <a:solidFill>
                             <a:srgbClr val="7A4F00"/>
                           </a:solidFill>
                         </a:rPr>
                         <a:t>[INPUT REQUIRED]</a:t>
                       </a:r>
-                      <a:endParaRPr lang="en-US" sz="1100" dirty="0"/>
+                      <a:endParaRPr lang="en-US" sz="1050" dirty="0"/>
                     </a:p>
                   </a:txBody>
                   <a:tcPr marL="73152" marR="73152" marT="45720" marB="45720" anchor="ctr">
@@ -24863,14 +24863,14 @@
                         <a:buNone/>
                       </a:pPr>
                       <a:r>
-                        <a:rPr lang="en-US" sz="1100" i="1" dirty="0">
+                        <a:rPr lang="en-US" sz="1050" i="1" dirty="0">
                           <a:solidFill>
                             <a:srgbClr val="7A4F00"/>
                           </a:solidFill>
                         </a:rPr>
                         <a:t>[INPUT]</a:t>
                       </a:r>
-                      <a:endParaRPr lang="en-US" sz="1100" dirty="0"/>
+                      <a:endParaRPr lang="en-US" sz="1050" dirty="0"/>
                     </a:p>
                   </a:txBody>
                   <a:tcPr marL="73152" marR="73152" marT="45720" marB="45720" anchor="ctr">
@@ -24898,7 +24898,7 @@
                   </a:tcPr>
                 </a:tc>
               </a:tr>
-              <a:tr h="512064">
+              <a:tr h="420624">
                 <a:tc>
                   <a:txBody>
                     <a:bodyPr/>
@@ -24908,14 +24908,14 @@
                         <a:buNone/>
                       </a:pPr>
                       <a:r>
-                        <a:rPr lang="en-US" sz="1100" b="1" dirty="0">
+                        <a:rPr lang="en-US" sz="1050" b="1" dirty="0">
                           <a:solidFill>
                             <a:srgbClr val="1F2937"/>
                           </a:solidFill>
                         </a:rPr>
-                        <a:t>ISO 27001 – Information security</a:t>
+                        <a:t>ISO/IEC 27001 – Information security (ISMS)</a:t>
                       </a:r>
-                      <a:endParaRPr lang="en-US" sz="1100" dirty="0"/>
+                      <a:endParaRPr lang="en-US" sz="1050" dirty="0"/>
                     </a:p>
                   </a:txBody>
                   <a:tcPr marL="73152" marR="73152" marT="45720" marB="45720" anchor="ctr">
@@ -24951,14 +24951,14 @@
                         <a:buNone/>
                       </a:pPr>
                       <a:r>
-                        <a:rPr lang="en-US" sz="1100" dirty="0">
+                        <a:rPr lang="en-US" sz="1050" dirty="0">
                           <a:solidFill>
                             <a:srgbClr val="1F2937"/>
                           </a:solidFill>
                         </a:rPr>
-                        <a:t>Protects patient-related data in cloud and dashboard</a:t>
+                        <a:t>Systematic protection of patient-related data across platform and dashboard</a:t>
                       </a:r>
-                      <a:endParaRPr lang="en-US" sz="1100" dirty="0"/>
+                      <a:endParaRPr lang="en-US" sz="1050" dirty="0"/>
                     </a:p>
                   </a:txBody>
                   <a:tcPr marL="73152" marR="73152" marT="45720" marB="45720" anchor="ctr">
@@ -24994,14 +24994,536 @@
                         <a:buNone/>
                       </a:pPr>
                       <a:r>
-                        <a:rPr lang="en-US" sz="1100" i="1" dirty="0">
+                        <a:rPr lang="en-US" sz="1050" dirty="0">
+                          <a:solidFill>
+                            <a:srgbClr val="1F2937"/>
+                          </a:solidFill>
+                        </a:rPr>
+                        <a:t>Certification planned — in progress</a:t>
+                      </a:r>
+                      <a:endParaRPr lang="en-US" sz="1050" dirty="0"/>
+                    </a:p>
+                  </a:txBody>
+                  <a:tcPr marL="73152" marR="73152" marT="45720" marB="45720" anchor="ctr">
+                    <a:lnL w="0" cap="flat" cmpd="sng" algn="ctr">
+                      <a:noFill/>
+                    </a:lnL>
+                    <a:lnR w="0" cap="flat" cmpd="sng" algn="ctr">
+                      <a:noFill/>
+                    </a:lnR>
+                    <a:lnT w="0" cap="flat" cmpd="sng" algn="ctr">
+                      <a:noFill/>
+                    </a:lnT>
+                    <a:lnB w="9525" cap="flat" cmpd="sng" algn="ctr">
+                      <a:solidFill>
+                        <a:srgbClr val="D5DCE6"/>
+                      </a:solidFill>
+                      <a:prstDash val="solid"/>
+                      <a:round/>
+                      <a:headEnd type="none" w="med" len="med"/>
+                      <a:tailEnd type="none" w="med" len="med"/>
+                    </a:lnB>
+                    <a:solidFill>
+                      <a:srgbClr val="F1F4F8"/>
+                    </a:solidFill>
+                  </a:tcPr>
+                </a:tc>
+                <a:tc>
+                  <a:txBody>
+                    <a:bodyPr/>
+                    <a:lstStyle/>
+                    <a:p>
+                      <a:pPr indent="0" marL="0">
+                        <a:buNone/>
+                      </a:pPr>
+                      <a:r>
+                        <a:rPr lang="en-US" sz="1050" dirty="0">
+                          <a:solidFill>
+                            <a:srgbClr val="1F2937"/>
+                          </a:solidFill>
+                        </a:rPr>
+                        <a:t>Target: [INPUT]</a:t>
+                      </a:r>
+                      <a:endParaRPr lang="en-US" sz="1050" dirty="0"/>
+                    </a:p>
+                  </a:txBody>
+                  <a:tcPr marL="73152" marR="73152" marT="45720" marB="45720" anchor="ctr">
+                    <a:lnL w="0" cap="flat" cmpd="sng" algn="ctr">
+                      <a:noFill/>
+                    </a:lnL>
+                    <a:lnR w="0" cap="flat" cmpd="sng" algn="ctr">
+                      <a:noFill/>
+                    </a:lnR>
+                    <a:lnT w="0" cap="flat" cmpd="sng" algn="ctr">
+                      <a:noFill/>
+                    </a:lnT>
+                    <a:lnB w="9525" cap="flat" cmpd="sng" algn="ctr">
+                      <a:solidFill>
+                        <a:srgbClr val="D5DCE6"/>
+                      </a:solidFill>
+                      <a:prstDash val="solid"/>
+                      <a:round/>
+                      <a:headEnd type="none" w="med" len="med"/>
+                      <a:tailEnd type="none" w="med" len="med"/>
+                    </a:lnB>
+                    <a:solidFill>
+                      <a:srgbClr val="F1F4F8"/>
+                    </a:solidFill>
+                  </a:tcPr>
+                </a:tc>
+              </a:tr>
+              <a:tr h="420624">
+                <a:tc>
+                  <a:txBody>
+                    <a:bodyPr/>
+                    <a:lstStyle/>
+                    <a:p>
+                      <a:pPr indent="0" marL="0">
+                        <a:buNone/>
+                      </a:pPr>
+                      <a:r>
+                        <a:rPr lang="en-US" sz="1050" b="1" dirty="0">
+                          <a:solidFill>
+                            <a:srgbClr val="1F2937"/>
+                          </a:solidFill>
+                        </a:rPr>
+                        <a:t>ISO/IEC 27017 – Cloud security controls</a:t>
+                      </a:r>
+                      <a:endParaRPr lang="en-US" sz="1050" dirty="0"/>
+                    </a:p>
+                  </a:txBody>
+                  <a:tcPr marL="73152" marR="73152" marT="45720" marB="45720" anchor="ctr">
+                    <a:lnL w="0" cap="flat" cmpd="sng" algn="ctr">
+                      <a:noFill/>
+                    </a:lnL>
+                    <a:lnR w="0" cap="flat" cmpd="sng" algn="ctr">
+                      <a:noFill/>
+                    </a:lnR>
+                    <a:lnT w="0" cap="flat" cmpd="sng" algn="ctr">
+                      <a:noFill/>
+                    </a:lnT>
+                    <a:lnB w="9525" cap="flat" cmpd="sng" algn="ctr">
+                      <a:solidFill>
+                        <a:srgbClr val="D5DCE6"/>
+                      </a:solidFill>
+                      <a:prstDash val="solid"/>
+                      <a:round/>
+                      <a:headEnd type="none" w="med" len="med"/>
+                      <a:tailEnd type="none" w="med" len="med"/>
+                    </a:lnB>
+                    <a:solidFill>
+                      <a:srgbClr val="FFFFFF"/>
+                    </a:solidFill>
+                  </a:tcPr>
+                </a:tc>
+                <a:tc>
+                  <a:txBody>
+                    <a:bodyPr/>
+                    <a:lstStyle/>
+                    <a:p>
+                      <a:pPr indent="0" marL="0">
+                        <a:buNone/>
+                      </a:pPr>
+                      <a:r>
+                        <a:rPr lang="en-US" sz="1050" dirty="0">
+                          <a:solidFill>
+                            <a:srgbClr val="1F2937"/>
+                          </a:solidFill>
+                        </a:rPr>
+                        <a:t>Security controls for the cloud platform hosting hospital data</a:t>
+                      </a:r>
+                      <a:endParaRPr lang="en-US" sz="1050" dirty="0"/>
+                    </a:p>
+                  </a:txBody>
+                  <a:tcPr marL="73152" marR="73152" marT="45720" marB="45720" anchor="ctr">
+                    <a:lnL w="0" cap="flat" cmpd="sng" algn="ctr">
+                      <a:noFill/>
+                    </a:lnL>
+                    <a:lnR w="0" cap="flat" cmpd="sng" algn="ctr">
+                      <a:noFill/>
+                    </a:lnR>
+                    <a:lnT w="0" cap="flat" cmpd="sng" algn="ctr">
+                      <a:noFill/>
+                    </a:lnT>
+                    <a:lnB w="9525" cap="flat" cmpd="sng" algn="ctr">
+                      <a:solidFill>
+                        <a:srgbClr val="D5DCE6"/>
+                      </a:solidFill>
+                      <a:prstDash val="solid"/>
+                      <a:round/>
+                      <a:headEnd type="none" w="med" len="med"/>
+                      <a:tailEnd type="none" w="med" len="med"/>
+                    </a:lnB>
+                    <a:solidFill>
+                      <a:srgbClr val="FFFFFF"/>
+                    </a:solidFill>
+                  </a:tcPr>
+                </a:tc>
+                <a:tc>
+                  <a:txBody>
+                    <a:bodyPr/>
+                    <a:lstStyle/>
+                    <a:p>
+                      <a:pPr indent="0" marL="0">
+                        <a:buNone/>
+                      </a:pPr>
+                      <a:r>
+                        <a:rPr lang="en-US" sz="1050" dirty="0">
+                          <a:solidFill>
+                            <a:srgbClr val="1F2937"/>
+                          </a:solidFill>
+                        </a:rPr>
+                        <a:t>Certification planned — in progress</a:t>
+                      </a:r>
+                      <a:endParaRPr lang="en-US" sz="1050" dirty="0"/>
+                    </a:p>
+                  </a:txBody>
+                  <a:tcPr marL="73152" marR="73152" marT="45720" marB="45720" anchor="ctr">
+                    <a:lnL w="0" cap="flat" cmpd="sng" algn="ctr">
+                      <a:noFill/>
+                    </a:lnL>
+                    <a:lnR w="0" cap="flat" cmpd="sng" algn="ctr">
+                      <a:noFill/>
+                    </a:lnR>
+                    <a:lnT w="0" cap="flat" cmpd="sng" algn="ctr">
+                      <a:noFill/>
+                    </a:lnT>
+                    <a:lnB w="9525" cap="flat" cmpd="sng" algn="ctr">
+                      <a:solidFill>
+                        <a:srgbClr val="D5DCE6"/>
+                      </a:solidFill>
+                      <a:prstDash val="solid"/>
+                      <a:round/>
+                      <a:headEnd type="none" w="med" len="med"/>
+                      <a:tailEnd type="none" w="med" len="med"/>
+                    </a:lnB>
+                    <a:solidFill>
+                      <a:srgbClr val="FFFFFF"/>
+                    </a:solidFill>
+                  </a:tcPr>
+                </a:tc>
+                <a:tc>
+                  <a:txBody>
+                    <a:bodyPr/>
+                    <a:lstStyle/>
+                    <a:p>
+                      <a:pPr indent="0" marL="0">
+                        <a:buNone/>
+                      </a:pPr>
+                      <a:r>
+                        <a:rPr lang="en-US" sz="1050" dirty="0">
+                          <a:solidFill>
+                            <a:srgbClr val="1F2937"/>
+                          </a:solidFill>
+                        </a:rPr>
+                        <a:t>Target: [INPUT]</a:t>
+                      </a:r>
+                      <a:endParaRPr lang="en-US" sz="1050" dirty="0"/>
+                    </a:p>
+                  </a:txBody>
+                  <a:tcPr marL="73152" marR="73152" marT="45720" marB="45720" anchor="ctr">
+                    <a:lnL w="0" cap="flat" cmpd="sng" algn="ctr">
+                      <a:noFill/>
+                    </a:lnL>
+                    <a:lnR w="0" cap="flat" cmpd="sng" algn="ctr">
+                      <a:noFill/>
+                    </a:lnR>
+                    <a:lnT w="0" cap="flat" cmpd="sng" algn="ctr">
+                      <a:noFill/>
+                    </a:lnT>
+                    <a:lnB w="9525" cap="flat" cmpd="sng" algn="ctr">
+                      <a:solidFill>
+                        <a:srgbClr val="D5DCE6"/>
+                      </a:solidFill>
+                      <a:prstDash val="solid"/>
+                      <a:round/>
+                      <a:headEnd type="none" w="med" len="med"/>
+                      <a:tailEnd type="none" w="med" len="med"/>
+                    </a:lnB>
+                    <a:solidFill>
+                      <a:srgbClr val="FFFFFF"/>
+                    </a:solidFill>
+                  </a:tcPr>
+                </a:tc>
+              </a:tr>
+              <a:tr h="420624">
+                <a:tc>
+                  <a:txBody>
+                    <a:bodyPr/>
+                    <a:lstStyle/>
+                    <a:p>
+                      <a:pPr indent="0" marL="0">
+                        <a:buNone/>
+                      </a:pPr>
+                      <a:r>
+                        <a:rPr lang="en-US" sz="1050" b="1" dirty="0">
+                          <a:solidFill>
+                            <a:srgbClr val="1F2937"/>
+                          </a:solidFill>
+                        </a:rPr>
+                        <a:t>ISO/IEC 27018 – PII protection in public cloud</a:t>
+                      </a:r>
+                      <a:endParaRPr lang="en-US" sz="1050" dirty="0"/>
+                    </a:p>
+                  </a:txBody>
+                  <a:tcPr marL="73152" marR="73152" marT="45720" marB="45720" anchor="ctr">
+                    <a:lnL w="0" cap="flat" cmpd="sng" algn="ctr">
+                      <a:noFill/>
+                    </a:lnL>
+                    <a:lnR w="0" cap="flat" cmpd="sng" algn="ctr">
+                      <a:noFill/>
+                    </a:lnR>
+                    <a:lnT w="0" cap="flat" cmpd="sng" algn="ctr">
+                      <a:noFill/>
+                    </a:lnT>
+                    <a:lnB w="9525" cap="flat" cmpd="sng" algn="ctr">
+                      <a:solidFill>
+                        <a:srgbClr val="D5DCE6"/>
+                      </a:solidFill>
+                      <a:prstDash val="solid"/>
+                      <a:round/>
+                      <a:headEnd type="none" w="med" len="med"/>
+                      <a:tailEnd type="none" w="med" len="med"/>
+                    </a:lnB>
+                    <a:solidFill>
+                      <a:srgbClr val="F1F4F8"/>
+                    </a:solidFill>
+                  </a:tcPr>
+                </a:tc>
+                <a:tc>
+                  <a:txBody>
+                    <a:bodyPr/>
+                    <a:lstStyle/>
+                    <a:p>
+                      <a:pPr indent="0" marL="0">
+                        <a:buNone/>
+                      </a:pPr>
+                      <a:r>
+                        <a:rPr lang="en-US" sz="1050" dirty="0">
+                          <a:solidFill>
+                            <a:srgbClr val="1F2937"/>
+                          </a:solidFill>
+                        </a:rPr>
+                        <a:t>Safeguards personal data processed in the cloud; supports PDPA compliance</a:t>
+                      </a:r>
+                      <a:endParaRPr lang="en-US" sz="1050" dirty="0"/>
+                    </a:p>
+                  </a:txBody>
+                  <a:tcPr marL="73152" marR="73152" marT="45720" marB="45720" anchor="ctr">
+                    <a:lnL w="0" cap="flat" cmpd="sng" algn="ctr">
+                      <a:noFill/>
+                    </a:lnL>
+                    <a:lnR w="0" cap="flat" cmpd="sng" algn="ctr">
+                      <a:noFill/>
+                    </a:lnR>
+                    <a:lnT w="0" cap="flat" cmpd="sng" algn="ctr">
+                      <a:noFill/>
+                    </a:lnT>
+                    <a:lnB w="9525" cap="flat" cmpd="sng" algn="ctr">
+                      <a:solidFill>
+                        <a:srgbClr val="D5DCE6"/>
+                      </a:solidFill>
+                      <a:prstDash val="solid"/>
+                      <a:round/>
+                      <a:headEnd type="none" w="med" len="med"/>
+                      <a:tailEnd type="none" w="med" len="med"/>
+                    </a:lnB>
+                    <a:solidFill>
+                      <a:srgbClr val="F1F4F8"/>
+                    </a:solidFill>
+                  </a:tcPr>
+                </a:tc>
+                <a:tc>
+                  <a:txBody>
+                    <a:bodyPr/>
+                    <a:lstStyle/>
+                    <a:p>
+                      <a:pPr indent="0" marL="0">
+                        <a:buNone/>
+                      </a:pPr>
+                      <a:r>
+                        <a:rPr lang="en-US" sz="1050" dirty="0">
+                          <a:solidFill>
+                            <a:srgbClr val="1F2937"/>
+                          </a:solidFill>
+                        </a:rPr>
+                        <a:t>Certification planned — in progress</a:t>
+                      </a:r>
+                      <a:endParaRPr lang="en-US" sz="1050" dirty="0"/>
+                    </a:p>
+                  </a:txBody>
+                  <a:tcPr marL="73152" marR="73152" marT="45720" marB="45720" anchor="ctr">
+                    <a:lnL w="0" cap="flat" cmpd="sng" algn="ctr">
+                      <a:noFill/>
+                    </a:lnL>
+                    <a:lnR w="0" cap="flat" cmpd="sng" algn="ctr">
+                      <a:noFill/>
+                    </a:lnR>
+                    <a:lnT w="0" cap="flat" cmpd="sng" algn="ctr">
+                      <a:noFill/>
+                    </a:lnT>
+                    <a:lnB w="9525" cap="flat" cmpd="sng" algn="ctr">
+                      <a:solidFill>
+                        <a:srgbClr val="D5DCE6"/>
+                      </a:solidFill>
+                      <a:prstDash val="solid"/>
+                      <a:round/>
+                      <a:headEnd type="none" w="med" len="med"/>
+                      <a:tailEnd type="none" w="med" len="med"/>
+                    </a:lnB>
+                    <a:solidFill>
+                      <a:srgbClr val="F1F4F8"/>
+                    </a:solidFill>
+                  </a:tcPr>
+                </a:tc>
+                <a:tc>
+                  <a:txBody>
+                    <a:bodyPr/>
+                    <a:lstStyle/>
+                    <a:p>
+                      <a:pPr indent="0" marL="0">
+                        <a:buNone/>
+                      </a:pPr>
+                      <a:r>
+                        <a:rPr lang="en-US" sz="1050" dirty="0">
+                          <a:solidFill>
+                            <a:srgbClr val="1F2937"/>
+                          </a:solidFill>
+                        </a:rPr>
+                        <a:t>Target: [INPUT]</a:t>
+                      </a:r>
+                      <a:endParaRPr lang="en-US" sz="1050" dirty="0"/>
+                    </a:p>
+                  </a:txBody>
+                  <a:tcPr marL="73152" marR="73152" marT="45720" marB="45720" anchor="ctr">
+                    <a:lnL w="0" cap="flat" cmpd="sng" algn="ctr">
+                      <a:noFill/>
+                    </a:lnL>
+                    <a:lnR w="0" cap="flat" cmpd="sng" algn="ctr">
+                      <a:noFill/>
+                    </a:lnR>
+                    <a:lnT w="0" cap="flat" cmpd="sng" algn="ctr">
+                      <a:noFill/>
+                    </a:lnT>
+                    <a:lnB w="9525" cap="flat" cmpd="sng" algn="ctr">
+                      <a:solidFill>
+                        <a:srgbClr val="D5DCE6"/>
+                      </a:solidFill>
+                      <a:prstDash val="solid"/>
+                      <a:round/>
+                      <a:headEnd type="none" w="med" len="med"/>
+                      <a:tailEnd type="none" w="med" len="med"/>
+                    </a:lnB>
+                    <a:solidFill>
+                      <a:srgbClr val="F1F4F8"/>
+                    </a:solidFill>
+                  </a:tcPr>
+                </a:tc>
+              </a:tr>
+              <a:tr h="420624">
+                <a:tc>
+                  <a:txBody>
+                    <a:bodyPr/>
+                    <a:lstStyle/>
+                    <a:p>
+                      <a:pPr indent="0" marL="0">
+                        <a:buNone/>
+                      </a:pPr>
+                      <a:r>
+                        <a:rPr lang="en-US" sz="1050" b="1" dirty="0">
+                          <a:solidFill>
+                            <a:srgbClr val="1F2937"/>
+                          </a:solidFill>
+                        </a:rPr>
+                        <a:t>ISO 14001 / ISO 45001</a:t>
+                      </a:r>
+                      <a:endParaRPr lang="en-US" sz="1050" dirty="0"/>
+                    </a:p>
+                  </a:txBody>
+                  <a:tcPr marL="73152" marR="73152" marT="45720" marB="45720" anchor="ctr">
+                    <a:lnL w="0" cap="flat" cmpd="sng" algn="ctr">
+                      <a:noFill/>
+                    </a:lnL>
+                    <a:lnR w="0" cap="flat" cmpd="sng" algn="ctr">
+                      <a:noFill/>
+                    </a:lnR>
+                    <a:lnT w="0" cap="flat" cmpd="sng" algn="ctr">
+                      <a:noFill/>
+                    </a:lnT>
+                    <a:lnB w="9525" cap="flat" cmpd="sng" algn="ctr">
+                      <a:solidFill>
+                        <a:srgbClr val="D5DCE6"/>
+                      </a:solidFill>
+                      <a:prstDash val="solid"/>
+                      <a:round/>
+                      <a:headEnd type="none" w="med" len="med"/>
+                      <a:tailEnd type="none" w="med" len="med"/>
+                    </a:lnB>
+                    <a:solidFill>
+                      <a:srgbClr val="FFFFFF"/>
+                    </a:solidFill>
+                  </a:tcPr>
+                </a:tc>
+                <a:tc>
+                  <a:txBody>
+                    <a:bodyPr/>
+                    <a:lstStyle/>
+                    <a:p>
+                      <a:pPr indent="0" marL="0">
+                        <a:buNone/>
+                      </a:pPr>
+                      <a:r>
+                        <a:rPr lang="en-US" sz="1050" dirty="0">
+                          <a:solidFill>
+                            <a:srgbClr val="1F2937"/>
+                          </a:solidFill>
+                        </a:rPr>
+                        <a:t>Aligns with ALPS's ISO14000 / OSHA requirements</a:t>
+                      </a:r>
+                      <a:endParaRPr lang="en-US" sz="1050" dirty="0"/>
+                    </a:p>
+                  </a:txBody>
+                  <a:tcPr marL="73152" marR="73152" marT="45720" marB="45720" anchor="ctr">
+                    <a:lnL w="0" cap="flat" cmpd="sng" algn="ctr">
+                      <a:noFill/>
+                    </a:lnL>
+                    <a:lnR w="0" cap="flat" cmpd="sng" algn="ctr">
+                      <a:noFill/>
+                    </a:lnR>
+                    <a:lnT w="0" cap="flat" cmpd="sng" algn="ctr">
+                      <a:noFill/>
+                    </a:lnT>
+                    <a:lnB w="9525" cap="flat" cmpd="sng" algn="ctr">
+                      <a:solidFill>
+                        <a:srgbClr val="D5DCE6"/>
+                      </a:solidFill>
+                      <a:prstDash val="solid"/>
+                      <a:round/>
+                      <a:headEnd type="none" w="med" len="med"/>
+                      <a:tailEnd type="none" w="med" len="med"/>
+                    </a:lnB>
+                    <a:solidFill>
+                      <a:srgbClr val="FFFFFF"/>
+                    </a:solidFill>
+                  </a:tcPr>
+                </a:tc>
+                <a:tc>
+                  <a:txBody>
+                    <a:bodyPr/>
+                    <a:lstStyle/>
+                    <a:p>
+                      <a:pPr indent="0" marL="0">
+                        <a:buNone/>
+                      </a:pPr>
+                      <a:r>
+                        <a:rPr lang="en-US" sz="1050" i="1" dirty="0">
                           <a:solidFill>
                             <a:srgbClr val="7A4F00"/>
                           </a:solidFill>
                         </a:rPr>
                         <a:t>[INPUT REQUIRED]</a:t>
                       </a:r>
-                      <a:endParaRPr lang="en-US" sz="1100" dirty="0"/>
+                      <a:endParaRPr lang="en-US" sz="1050" dirty="0"/>
                     </a:p>
                   </a:txBody>
                   <a:tcPr marL="73152" marR="73152" marT="45720" marB="45720" anchor="ctr">
@@ -25037,14 +25559,14 @@
                         <a:buNone/>
                       </a:pPr>
                       <a:r>
-                        <a:rPr lang="en-US" sz="1100" i="1" dirty="0">
+                        <a:rPr lang="en-US" sz="1050" i="1" dirty="0">
                           <a:solidFill>
                             <a:srgbClr val="7A4F00"/>
                           </a:solidFill>
                         </a:rPr>
                         <a:t>[INPUT]</a:t>
                       </a:r>
-                      <a:endParaRPr lang="en-US" sz="1100" dirty="0"/>
+                      <a:endParaRPr lang="en-US" sz="1050" dirty="0"/>
                     </a:p>
                   </a:txBody>
                   <a:tcPr marL="73152" marR="73152" marT="45720" marB="45720" anchor="ctr">
@@ -25072,7 +25594,7 @@
                   </a:tcPr>
                 </a:tc>
               </a:tr>
-              <a:tr h="512064">
+              <a:tr h="420624">
                 <a:tc>
                   <a:txBody>
                     <a:bodyPr/>
@@ -25082,14 +25604,188 @@
                         <a:buNone/>
                       </a:pPr>
                       <a:r>
-                        <a:rPr lang="en-US" sz="1100" b="1" dirty="0">
+                        <a:rPr lang="en-US" sz="1050" b="1" dirty="0">
                           <a:solidFill>
                             <a:srgbClr val="1F2937"/>
                           </a:solidFill>
                         </a:rPr>
-                        <a:t>ISO 14001 / ISO 45001</a:t>
+                        <a:t>IMDA – network devices (relay)</a:t>
                       </a:r>
-                      <a:endParaRPr lang="en-US" sz="1100" dirty="0"/>
+                      <a:endParaRPr lang="en-US" sz="1050" dirty="0"/>
+                    </a:p>
+                  </a:txBody>
+                  <a:tcPr marL="73152" marR="73152" marT="45720" marB="45720" anchor="ctr">
+                    <a:lnL w="0" cap="flat" cmpd="sng" algn="ctr">
+                      <a:noFill/>
+                    </a:lnL>
+                    <a:lnR w="0" cap="flat" cmpd="sng" algn="ctr">
+                      <a:noFill/>
+                    </a:lnR>
+                    <a:lnT w="0" cap="flat" cmpd="sng" algn="ctr">
+                      <a:noFill/>
+                    </a:lnT>
+                    <a:lnB w="9525" cap="flat" cmpd="sng" algn="ctr">
+                      <a:solidFill>
+                        <a:srgbClr val="D5DCE6"/>
+                      </a:solidFill>
+                      <a:prstDash val="solid"/>
+                      <a:round/>
+                      <a:headEnd type="none" w="med" len="med"/>
+                      <a:tailEnd type="none" w="med" len="med"/>
+                    </a:lnB>
+                    <a:solidFill>
+                      <a:srgbClr val="F1F4F8"/>
+                    </a:solidFill>
+                  </a:tcPr>
+                </a:tc>
+                <a:tc>
+                  <a:txBody>
+                    <a:bodyPr/>
+                    <a:lstStyle/>
+                    <a:p>
+                      <a:pPr indent="0" marL="0">
+                        <a:buNone/>
+                      </a:pPr>
+                      <a:r>
+                        <a:rPr lang="en-US" sz="1050" dirty="0">
+                          <a:solidFill>
+                            <a:srgbClr val="1F2937"/>
+                          </a:solidFill>
+                        </a:rPr>
+                        <a:t>Relay / Wi-Fi radio equipment lawfully connected in Singapore</a:t>
+                      </a:r>
+                      <a:endParaRPr lang="en-US" sz="1050" dirty="0"/>
+                    </a:p>
+                  </a:txBody>
+                  <a:tcPr marL="73152" marR="73152" marT="45720" marB="45720" anchor="ctr">
+                    <a:lnL w="0" cap="flat" cmpd="sng" algn="ctr">
+                      <a:noFill/>
+                    </a:lnL>
+                    <a:lnR w="0" cap="flat" cmpd="sng" algn="ctr">
+                      <a:noFill/>
+                    </a:lnR>
+                    <a:lnT w="0" cap="flat" cmpd="sng" algn="ctr">
+                      <a:noFill/>
+                    </a:lnT>
+                    <a:lnB w="9525" cap="flat" cmpd="sng" algn="ctr">
+                      <a:solidFill>
+                        <a:srgbClr val="D5DCE6"/>
+                      </a:solidFill>
+                      <a:prstDash val="solid"/>
+                      <a:round/>
+                      <a:headEnd type="none" w="med" len="med"/>
+                      <a:tailEnd type="none" w="med" len="med"/>
+                    </a:lnB>
+                    <a:solidFill>
+                      <a:srgbClr val="F1F4F8"/>
+                    </a:solidFill>
+                  </a:tcPr>
+                </a:tc>
+                <a:tc>
+                  <a:txBody>
+                    <a:bodyPr/>
+                    <a:lstStyle/>
+                    <a:p>
+                      <a:pPr indent="0" marL="0">
+                        <a:buNone/>
+                      </a:pPr>
+                      <a:r>
+                        <a:rPr lang="en-US" sz="1050" i="1" dirty="0">
+                          <a:solidFill>
+                            <a:srgbClr val="7A4F00"/>
+                          </a:solidFill>
+                        </a:rPr>
+                        <a:t>[INPUT REQUIRED] registration / label no.</a:t>
+                      </a:r>
+                      <a:endParaRPr lang="en-US" sz="1050" dirty="0"/>
+                    </a:p>
+                  </a:txBody>
+                  <a:tcPr marL="73152" marR="73152" marT="45720" marB="45720" anchor="ctr">
+                    <a:lnL w="0" cap="flat" cmpd="sng" algn="ctr">
+                      <a:noFill/>
+                    </a:lnL>
+                    <a:lnR w="0" cap="flat" cmpd="sng" algn="ctr">
+                      <a:noFill/>
+                    </a:lnR>
+                    <a:lnT w="0" cap="flat" cmpd="sng" algn="ctr">
+                      <a:noFill/>
+                    </a:lnT>
+                    <a:lnB w="9525" cap="flat" cmpd="sng" algn="ctr">
+                      <a:solidFill>
+                        <a:srgbClr val="D5DCE6"/>
+                      </a:solidFill>
+                      <a:prstDash val="solid"/>
+                      <a:round/>
+                      <a:headEnd type="none" w="med" len="med"/>
+                      <a:tailEnd type="none" w="med" len="med"/>
+                    </a:lnB>
+                    <a:solidFill>
+                      <a:srgbClr val="FFF4D6"/>
+                    </a:solidFill>
+                  </a:tcPr>
+                </a:tc>
+                <a:tc>
+                  <a:txBody>
+                    <a:bodyPr/>
+                    <a:lstStyle/>
+                    <a:p>
+                      <a:pPr indent="0" marL="0">
+                        <a:buNone/>
+                      </a:pPr>
+                      <a:r>
+                        <a:rPr lang="en-US" sz="1050" i="1" dirty="0">
+                          <a:solidFill>
+                            <a:srgbClr val="7A4F00"/>
+                          </a:solidFill>
+                        </a:rPr>
+                        <a:t>[INPUT]</a:t>
+                      </a:r>
+                      <a:endParaRPr lang="en-US" sz="1050" dirty="0"/>
+                    </a:p>
+                  </a:txBody>
+                  <a:tcPr marL="73152" marR="73152" marT="45720" marB="45720" anchor="ctr">
+                    <a:lnL w="0" cap="flat" cmpd="sng" algn="ctr">
+                      <a:noFill/>
+                    </a:lnL>
+                    <a:lnR w="0" cap="flat" cmpd="sng" algn="ctr">
+                      <a:noFill/>
+                    </a:lnR>
+                    <a:lnT w="0" cap="flat" cmpd="sng" algn="ctr">
+                      <a:noFill/>
+                    </a:lnT>
+                    <a:lnB w="9525" cap="flat" cmpd="sng" algn="ctr">
+                      <a:solidFill>
+                        <a:srgbClr val="D5DCE6"/>
+                      </a:solidFill>
+                      <a:prstDash val="solid"/>
+                      <a:round/>
+                      <a:headEnd type="none" w="med" len="med"/>
+                      <a:tailEnd type="none" w="med" len="med"/>
+                    </a:lnB>
+                    <a:solidFill>
+                      <a:srgbClr val="FFF4D6"/>
+                    </a:solidFill>
+                  </a:tcPr>
+                </a:tc>
+              </a:tr>
+              <a:tr h="420624">
+                <a:tc>
+                  <a:txBody>
+                    <a:bodyPr/>
+                    <a:lstStyle/>
+                    <a:p>
+                      <a:pPr indent="0" marL="0">
+                        <a:buNone/>
+                      </a:pPr>
+                      <a:r>
+                        <a:rPr lang="en-US" sz="1050" b="1" dirty="0">
+                          <a:solidFill>
+                            <a:srgbClr val="1F2937"/>
+                          </a:solidFill>
+                        </a:rPr>
+                        <a:t>HSA – medical device registration</a:t>
+                      </a:r>
+                      <a:endParaRPr lang="en-US" sz="1050" dirty="0"/>
                     </a:p>
                   </a:txBody>
                   <a:tcPr marL="73152" marR="73152" marT="45720" marB="45720" anchor="ctr">
@@ -25125,14 +25821,14 @@
                         <a:buNone/>
                       </a:pPr>
                       <a:r>
-                        <a:rPr lang="en-US" sz="1100" dirty="0">
+                        <a:rPr lang="en-US" sz="1050" dirty="0">
                           <a:solidFill>
                             <a:srgbClr val="1F2937"/>
                           </a:solidFill>
                         </a:rPr>
-                        <a:t>Aligns with ALPS's ISO14000 / OSHA requirements</a:t>
+                        <a:t>RFP requires registration for Class B/C/D (before 1 May 2010) and Class A (before 1 May 2011) — confirm applicability</a:t>
                       </a:r>
-                      <a:endParaRPr lang="en-US" sz="1100" dirty="0"/>
+                      <a:endParaRPr lang="en-US" sz="1050" dirty="0"/>
                     </a:p>
                   </a:txBody>
                   <a:tcPr marL="73152" marR="73152" marT="45720" marB="45720" anchor="ctr">
@@ -25168,14 +25864,14 @@
                         <a:buNone/>
                       </a:pPr>
                       <a:r>
-                        <a:rPr lang="en-US" sz="1100" i="1" dirty="0">
+                        <a:rPr lang="en-US" sz="1050" i="1" dirty="0">
                           <a:solidFill>
                             <a:srgbClr val="7A4F00"/>
                           </a:solidFill>
                         </a:rPr>
-                        <a:t>[INPUT REQUIRED]</a:t>
+                        <a:t>[INPUT REQUIRED] class &amp; reg. no.</a:t>
                       </a:r>
-                      <a:endParaRPr lang="en-US" sz="1100" dirty="0"/>
+                      <a:endParaRPr lang="en-US" sz="1050" dirty="0"/>
                     </a:p>
                   </a:txBody>
                   <a:tcPr marL="73152" marR="73152" marT="45720" marB="45720" anchor="ctr">
@@ -25211,362 +25907,14 @@
                         <a:buNone/>
                       </a:pPr>
                       <a:r>
-                        <a:rPr lang="en-US" sz="1100" i="1" dirty="0">
+                        <a:rPr lang="en-US" sz="1050" i="1" dirty="0">
                           <a:solidFill>
                             <a:srgbClr val="7A4F00"/>
                           </a:solidFill>
                         </a:rPr>
                         <a:t>[INPUT]</a:t>
                       </a:r>
-                      <a:endParaRPr lang="en-US" sz="1100" dirty="0"/>
-                    </a:p>
-                  </a:txBody>
-                  <a:tcPr marL="73152" marR="73152" marT="45720" marB="45720" anchor="ctr">
-                    <a:lnL w="0" cap="flat" cmpd="sng" algn="ctr">
-                      <a:noFill/>
-                    </a:lnL>
-                    <a:lnR w="0" cap="flat" cmpd="sng" algn="ctr">
-                      <a:noFill/>
-                    </a:lnR>
-                    <a:lnT w="0" cap="flat" cmpd="sng" algn="ctr">
-                      <a:noFill/>
-                    </a:lnT>
-                    <a:lnB w="9525" cap="flat" cmpd="sng" algn="ctr">
-                      <a:solidFill>
-                        <a:srgbClr val="D5DCE6"/>
-                      </a:solidFill>
-                      <a:prstDash val="solid"/>
-                      <a:round/>
-                      <a:headEnd type="none" w="med" len="med"/>
-                      <a:tailEnd type="none" w="med" len="med"/>
-                    </a:lnB>
-                    <a:solidFill>
-                      <a:srgbClr val="FFF4D6"/>
-                    </a:solidFill>
-                  </a:tcPr>
-                </a:tc>
-              </a:tr>
-              <a:tr h="512064">
-                <a:tc>
-                  <a:txBody>
-                    <a:bodyPr/>
-                    <a:lstStyle/>
-                    <a:p>
-                      <a:pPr indent="0" marL="0">
-                        <a:buNone/>
-                      </a:pPr>
-                      <a:r>
-                        <a:rPr lang="en-US" sz="1100" b="1" dirty="0">
-                          <a:solidFill>
-                            <a:srgbClr val="1F2937"/>
-                          </a:solidFill>
-                        </a:rPr>
-                        <a:t>IMDA – network devices (relay)</a:t>
-                      </a:r>
-                      <a:endParaRPr lang="en-US" sz="1100" dirty="0"/>
-                    </a:p>
-                  </a:txBody>
-                  <a:tcPr marL="73152" marR="73152" marT="45720" marB="45720" anchor="ctr">
-                    <a:lnL w="0" cap="flat" cmpd="sng" algn="ctr">
-                      <a:noFill/>
-                    </a:lnL>
-                    <a:lnR w="0" cap="flat" cmpd="sng" algn="ctr">
-                      <a:noFill/>
-                    </a:lnR>
-                    <a:lnT w="0" cap="flat" cmpd="sng" algn="ctr">
-                      <a:noFill/>
-                    </a:lnT>
-                    <a:lnB w="9525" cap="flat" cmpd="sng" algn="ctr">
-                      <a:solidFill>
-                        <a:srgbClr val="D5DCE6"/>
-                      </a:solidFill>
-                      <a:prstDash val="solid"/>
-                      <a:round/>
-                      <a:headEnd type="none" w="med" len="med"/>
-                      <a:tailEnd type="none" w="med" len="med"/>
-                    </a:lnB>
-                    <a:solidFill>
-                      <a:srgbClr val="F1F4F8"/>
-                    </a:solidFill>
-                  </a:tcPr>
-                </a:tc>
-                <a:tc>
-                  <a:txBody>
-                    <a:bodyPr/>
-                    <a:lstStyle/>
-                    <a:p>
-                      <a:pPr indent="0" marL="0">
-                        <a:buNone/>
-                      </a:pPr>
-                      <a:r>
-                        <a:rPr lang="en-US" sz="1100" dirty="0">
-                          <a:solidFill>
-                            <a:srgbClr val="1F2937"/>
-                          </a:solidFill>
-                        </a:rPr>
-                        <a:t>Relay / Wi-Fi radio equipment lawfully connected in Singapore</a:t>
-                      </a:r>
-                      <a:endParaRPr lang="en-US" sz="1100" dirty="0"/>
-                    </a:p>
-                  </a:txBody>
-                  <a:tcPr marL="73152" marR="73152" marT="45720" marB="45720" anchor="ctr">
-                    <a:lnL w="0" cap="flat" cmpd="sng" algn="ctr">
-                      <a:noFill/>
-                    </a:lnL>
-                    <a:lnR w="0" cap="flat" cmpd="sng" algn="ctr">
-                      <a:noFill/>
-                    </a:lnR>
-                    <a:lnT w="0" cap="flat" cmpd="sng" algn="ctr">
-                      <a:noFill/>
-                    </a:lnT>
-                    <a:lnB w="9525" cap="flat" cmpd="sng" algn="ctr">
-                      <a:solidFill>
-                        <a:srgbClr val="D5DCE6"/>
-                      </a:solidFill>
-                      <a:prstDash val="solid"/>
-                      <a:round/>
-                      <a:headEnd type="none" w="med" len="med"/>
-                      <a:tailEnd type="none" w="med" len="med"/>
-                    </a:lnB>
-                    <a:solidFill>
-                      <a:srgbClr val="F1F4F8"/>
-                    </a:solidFill>
-                  </a:tcPr>
-                </a:tc>
-                <a:tc>
-                  <a:txBody>
-                    <a:bodyPr/>
-                    <a:lstStyle/>
-                    <a:p>
-                      <a:pPr indent="0" marL="0">
-                        <a:buNone/>
-                      </a:pPr>
-                      <a:r>
-                        <a:rPr lang="en-US" sz="1100" i="1" dirty="0">
-                          <a:solidFill>
-                            <a:srgbClr val="7A4F00"/>
-                          </a:solidFill>
-                        </a:rPr>
-                        <a:t>[INPUT REQUIRED] registration / label no.</a:t>
-                      </a:r>
-                      <a:endParaRPr lang="en-US" sz="1100" dirty="0"/>
-                    </a:p>
-                  </a:txBody>
-                  <a:tcPr marL="73152" marR="73152" marT="45720" marB="45720" anchor="ctr">
-                    <a:lnL w="0" cap="flat" cmpd="sng" algn="ctr">
-                      <a:noFill/>
-                    </a:lnL>
-                    <a:lnR w="0" cap="flat" cmpd="sng" algn="ctr">
-                      <a:noFill/>
-                    </a:lnR>
-                    <a:lnT w="0" cap="flat" cmpd="sng" algn="ctr">
-                      <a:noFill/>
-                    </a:lnT>
-                    <a:lnB w="9525" cap="flat" cmpd="sng" algn="ctr">
-                      <a:solidFill>
-                        <a:srgbClr val="D5DCE6"/>
-                      </a:solidFill>
-                      <a:prstDash val="solid"/>
-                      <a:round/>
-                      <a:headEnd type="none" w="med" len="med"/>
-                      <a:tailEnd type="none" w="med" len="med"/>
-                    </a:lnB>
-                    <a:solidFill>
-                      <a:srgbClr val="FFF4D6"/>
-                    </a:solidFill>
-                  </a:tcPr>
-                </a:tc>
-                <a:tc>
-                  <a:txBody>
-                    <a:bodyPr/>
-                    <a:lstStyle/>
-                    <a:p>
-                      <a:pPr indent="0" marL="0">
-                        <a:buNone/>
-                      </a:pPr>
-                      <a:r>
-                        <a:rPr lang="en-US" sz="1100" i="1" dirty="0">
-                          <a:solidFill>
-                            <a:srgbClr val="7A4F00"/>
-                          </a:solidFill>
-                        </a:rPr>
-                        <a:t>[INPUT]</a:t>
-                      </a:r>
-                      <a:endParaRPr lang="en-US" sz="1100" dirty="0"/>
-                    </a:p>
-                  </a:txBody>
-                  <a:tcPr marL="73152" marR="73152" marT="45720" marB="45720" anchor="ctr">
-                    <a:lnL w="0" cap="flat" cmpd="sng" algn="ctr">
-                      <a:noFill/>
-                    </a:lnL>
-                    <a:lnR w="0" cap="flat" cmpd="sng" algn="ctr">
-                      <a:noFill/>
-                    </a:lnR>
-                    <a:lnT w="0" cap="flat" cmpd="sng" algn="ctr">
-                      <a:noFill/>
-                    </a:lnT>
-                    <a:lnB w="9525" cap="flat" cmpd="sng" algn="ctr">
-                      <a:solidFill>
-                        <a:srgbClr val="D5DCE6"/>
-                      </a:solidFill>
-                      <a:prstDash val="solid"/>
-                      <a:round/>
-                      <a:headEnd type="none" w="med" len="med"/>
-                      <a:tailEnd type="none" w="med" len="med"/>
-                    </a:lnB>
-                    <a:solidFill>
-                      <a:srgbClr val="FFF4D6"/>
-                    </a:solidFill>
-                  </a:tcPr>
-                </a:tc>
-              </a:tr>
-              <a:tr h="512064">
-                <a:tc>
-                  <a:txBody>
-                    <a:bodyPr/>
-                    <a:lstStyle/>
-                    <a:p>
-                      <a:pPr indent="0" marL="0">
-                        <a:buNone/>
-                      </a:pPr>
-                      <a:r>
-                        <a:rPr lang="en-US" sz="1100" b="1" dirty="0">
-                          <a:solidFill>
-                            <a:srgbClr val="1F2937"/>
-                          </a:solidFill>
-                        </a:rPr>
-                        <a:t>HSA – medical device registration</a:t>
-                      </a:r>
-                      <a:endParaRPr lang="en-US" sz="1100" dirty="0"/>
-                    </a:p>
-                  </a:txBody>
-                  <a:tcPr marL="73152" marR="73152" marT="45720" marB="45720" anchor="ctr">
-                    <a:lnL w="0" cap="flat" cmpd="sng" algn="ctr">
-                      <a:noFill/>
-                    </a:lnL>
-                    <a:lnR w="0" cap="flat" cmpd="sng" algn="ctr">
-                      <a:noFill/>
-                    </a:lnR>
-                    <a:lnT w="0" cap="flat" cmpd="sng" algn="ctr">
-                      <a:noFill/>
-                    </a:lnT>
-                    <a:lnB w="9525" cap="flat" cmpd="sng" algn="ctr">
-                      <a:solidFill>
-                        <a:srgbClr val="D5DCE6"/>
-                      </a:solidFill>
-                      <a:prstDash val="solid"/>
-                      <a:round/>
-                      <a:headEnd type="none" w="med" len="med"/>
-                      <a:tailEnd type="none" w="med" len="med"/>
-                    </a:lnB>
-                    <a:solidFill>
-                      <a:srgbClr val="FFFFFF"/>
-                    </a:solidFill>
-                  </a:tcPr>
-                </a:tc>
-                <a:tc>
-                  <a:txBody>
-                    <a:bodyPr/>
-                    <a:lstStyle/>
-                    <a:p>
-                      <a:pPr indent="0" marL="0">
-                        <a:buNone/>
-                      </a:pPr>
-                      <a:r>
-                        <a:rPr lang="en-US" sz="1100" dirty="0">
-                          <a:solidFill>
-                            <a:srgbClr val="1F2937"/>
-                          </a:solidFill>
-                        </a:rPr>
-                        <a:t>RFP requires registration for Class B/C/D (before 1 May 2010) and Class A (before 1 May 2011) — confirm applicability</a:t>
-                      </a:r>
-                      <a:endParaRPr lang="en-US" sz="1100" dirty="0"/>
-                    </a:p>
-                  </a:txBody>
-                  <a:tcPr marL="73152" marR="73152" marT="45720" marB="45720" anchor="ctr">
-                    <a:lnL w="0" cap="flat" cmpd="sng" algn="ctr">
-                      <a:noFill/>
-                    </a:lnL>
-                    <a:lnR w="0" cap="flat" cmpd="sng" algn="ctr">
-                      <a:noFill/>
-                    </a:lnR>
-                    <a:lnT w="0" cap="flat" cmpd="sng" algn="ctr">
-                      <a:noFill/>
-                    </a:lnT>
-                    <a:lnB w="9525" cap="flat" cmpd="sng" algn="ctr">
-                      <a:solidFill>
-                        <a:srgbClr val="D5DCE6"/>
-                      </a:solidFill>
-                      <a:prstDash val="solid"/>
-                      <a:round/>
-                      <a:headEnd type="none" w="med" len="med"/>
-                      <a:tailEnd type="none" w="med" len="med"/>
-                    </a:lnB>
-                    <a:solidFill>
-                      <a:srgbClr val="FFFFFF"/>
-                    </a:solidFill>
-                  </a:tcPr>
-                </a:tc>
-                <a:tc>
-                  <a:txBody>
-                    <a:bodyPr/>
-                    <a:lstStyle/>
-                    <a:p>
-                      <a:pPr indent="0" marL="0">
-                        <a:buNone/>
-                      </a:pPr>
-                      <a:r>
-                        <a:rPr lang="en-US" sz="1100" i="1" dirty="0">
-                          <a:solidFill>
-                            <a:srgbClr val="7A4F00"/>
-                          </a:solidFill>
-                        </a:rPr>
-                        <a:t>[INPUT REQUIRED] class &amp; reg. no.</a:t>
-                      </a:r>
-                      <a:endParaRPr lang="en-US" sz="1100" dirty="0"/>
-                    </a:p>
-                  </a:txBody>
-                  <a:tcPr marL="73152" marR="73152" marT="45720" marB="45720" anchor="ctr">
-                    <a:lnL w="0" cap="flat" cmpd="sng" algn="ctr">
-                      <a:noFill/>
-                    </a:lnL>
-                    <a:lnR w="0" cap="flat" cmpd="sng" algn="ctr">
-                      <a:noFill/>
-                    </a:lnR>
-                    <a:lnT w="0" cap="flat" cmpd="sng" algn="ctr">
-                      <a:noFill/>
-                    </a:lnT>
-                    <a:lnB w="9525" cap="flat" cmpd="sng" algn="ctr">
-                      <a:solidFill>
-                        <a:srgbClr val="D5DCE6"/>
-                      </a:solidFill>
-                      <a:prstDash val="solid"/>
-                      <a:round/>
-                      <a:headEnd type="none" w="med" len="med"/>
-                      <a:tailEnd type="none" w="med" len="med"/>
-                    </a:lnB>
-                    <a:solidFill>
-                      <a:srgbClr val="FFF4D6"/>
-                    </a:solidFill>
-                  </a:tcPr>
-                </a:tc>
-                <a:tc>
-                  <a:txBody>
-                    <a:bodyPr/>
-                    <a:lstStyle/>
-                    <a:p>
-                      <a:pPr indent="0" marL="0">
-                        <a:buNone/>
-                      </a:pPr>
-                      <a:r>
-                        <a:rPr lang="en-US" sz="1100" i="1" dirty="0">
-                          <a:solidFill>
-                            <a:srgbClr val="7A4F00"/>
-                          </a:solidFill>
-                        </a:rPr>
-                        <a:t>[INPUT]</a:t>
-                      </a:r>
-                      <a:endParaRPr lang="en-US" sz="1100" dirty="0"/>
+                      <a:endParaRPr lang="en-US" sz="1050" dirty="0"/>
                     </a:p>
                   </a:txBody>
                   <a:tcPr marL="73152" marR="73152" marT="45720" marB="45720" anchor="ctr">

</xml_diff>